<commit_message>
small changes to Stein_Estimator
</commit_message>
<xml_diff>
--- a/Stein_Estimator.pptx
+++ b/Stein_Estimator.pptx
@@ -263,7 +263,7 @@
           <a:p>
             <a:fld id="{EE65A1C1-DAB8-144D-91BF-92D4901901FF}" type="datetimeFigureOut">
               <a:rPr lang="en-US" smtClean="0"/>
-              <a:t>3/9/20</a:t>
+              <a:t>3/11/20</a:t>
             </a:fld>
             <a:endParaRPr lang="en-US"/>
           </a:p>
@@ -461,7 +461,7 @@
           <a:p>
             <a:fld id="{EE65A1C1-DAB8-144D-91BF-92D4901901FF}" type="datetimeFigureOut">
               <a:rPr lang="en-US" smtClean="0"/>
-              <a:t>3/9/20</a:t>
+              <a:t>3/11/20</a:t>
             </a:fld>
             <a:endParaRPr lang="en-US"/>
           </a:p>
@@ -669,7 +669,7 @@
           <a:p>
             <a:fld id="{EE65A1C1-DAB8-144D-91BF-92D4901901FF}" type="datetimeFigureOut">
               <a:rPr lang="en-US" smtClean="0"/>
-              <a:t>3/9/20</a:t>
+              <a:t>3/11/20</a:t>
             </a:fld>
             <a:endParaRPr lang="en-US"/>
           </a:p>
@@ -867,7 +867,7 @@
           <a:p>
             <a:fld id="{EE65A1C1-DAB8-144D-91BF-92D4901901FF}" type="datetimeFigureOut">
               <a:rPr lang="en-US" smtClean="0"/>
-              <a:t>3/9/20</a:t>
+              <a:t>3/11/20</a:t>
             </a:fld>
             <a:endParaRPr lang="en-US"/>
           </a:p>
@@ -1142,7 +1142,7 @@
           <a:p>
             <a:fld id="{EE65A1C1-DAB8-144D-91BF-92D4901901FF}" type="datetimeFigureOut">
               <a:rPr lang="en-US" smtClean="0"/>
-              <a:t>3/9/20</a:t>
+              <a:t>3/11/20</a:t>
             </a:fld>
             <a:endParaRPr lang="en-US"/>
           </a:p>
@@ -1407,7 +1407,7 @@
           <a:p>
             <a:fld id="{EE65A1C1-DAB8-144D-91BF-92D4901901FF}" type="datetimeFigureOut">
               <a:rPr lang="en-US" smtClean="0"/>
-              <a:t>3/9/20</a:t>
+              <a:t>3/11/20</a:t>
             </a:fld>
             <a:endParaRPr lang="en-US"/>
           </a:p>
@@ -1819,7 +1819,7 @@
           <a:p>
             <a:fld id="{EE65A1C1-DAB8-144D-91BF-92D4901901FF}" type="datetimeFigureOut">
               <a:rPr lang="en-US" smtClean="0"/>
-              <a:t>3/9/20</a:t>
+              <a:t>3/11/20</a:t>
             </a:fld>
             <a:endParaRPr lang="en-US"/>
           </a:p>
@@ -1960,7 +1960,7 @@
           <a:p>
             <a:fld id="{EE65A1C1-DAB8-144D-91BF-92D4901901FF}" type="datetimeFigureOut">
               <a:rPr lang="en-US" smtClean="0"/>
-              <a:t>3/9/20</a:t>
+              <a:t>3/11/20</a:t>
             </a:fld>
             <a:endParaRPr lang="en-US"/>
           </a:p>
@@ -2073,7 +2073,7 @@
           <a:p>
             <a:fld id="{EE65A1C1-DAB8-144D-91BF-92D4901901FF}" type="datetimeFigureOut">
               <a:rPr lang="en-US" smtClean="0"/>
-              <a:t>3/9/20</a:t>
+              <a:t>3/11/20</a:t>
             </a:fld>
             <a:endParaRPr lang="en-US"/>
           </a:p>
@@ -2384,7 +2384,7 @@
           <a:p>
             <a:fld id="{EE65A1C1-DAB8-144D-91BF-92D4901901FF}" type="datetimeFigureOut">
               <a:rPr lang="en-US" smtClean="0"/>
-              <a:t>3/9/20</a:t>
+              <a:t>3/11/20</a:t>
             </a:fld>
             <a:endParaRPr lang="en-US"/>
           </a:p>
@@ -2672,7 +2672,7 @@
           <a:p>
             <a:fld id="{EE65A1C1-DAB8-144D-91BF-92D4901901FF}" type="datetimeFigureOut">
               <a:rPr lang="en-US" smtClean="0"/>
-              <a:t>3/9/20</a:t>
+              <a:t>3/11/20</a:t>
             </a:fld>
             <a:endParaRPr lang="en-US"/>
           </a:p>
@@ -2913,7 +2913,7 @@
           <a:p>
             <a:fld id="{EE65A1C1-DAB8-144D-91BF-92D4901901FF}" type="datetimeFigureOut">
               <a:rPr lang="en-US" smtClean="0"/>
-              <a:t>3/9/20</a:t>
+              <a:t>3/11/20</a:t>
             </a:fld>
             <a:endParaRPr lang="en-US"/>
           </a:p>
@@ -4276,7 +4276,7 @@
           <a:p>
             <a:r>
               <a:rPr lang="en-US" dirty="0"/>
-              <a:t>In the Scientific American article, </a:t>
+              <a:t>In this "Scientific American" article, </a:t>
             </a:r>
             <a:r>
               <a:rPr lang="en-US" dirty="0" err="1"/>
@@ -5295,7 +5295,7 @@
           <a:p>
             <a:r>
               <a:rPr lang="en-US" dirty="0"/>
-              <a:t>Note: the abbreviation "SURE" may also relate to "Seemingly Unrelated Regression Equations" describing the SUR model proposed by Arnold Zellner in (1962.</a:t>
+              <a:t>Note: the abbreviation "SURE" may also relate to "Seemingly Unrelated Regression Equations" describing the SUR model proposed by Arnold Zellner in 1962.</a:t>
             </a:r>
           </a:p>
         </p:txBody>

</xml_diff>